<commit_message>
Big change to modify for error
</commit_message>
<xml_diff>
--- a/test/RQ3_test/Evaluation_rubrics.pptx
+++ b/test/RQ3_test/Evaluation_rubrics.pptx
@@ -1,6 +1,6 @@
 
 <file path=ppt/presentation.xml><?xml version="1.0" encoding="utf-8"?>
-<p:presentation xmlns:a="http://schemas.openxmlformats.org/drawingml/2006/main" xmlns:r="http://schemas.openxmlformats.org/officeDocument/2006/relationships" xmlns:p="http://schemas.openxmlformats.org/presentationml/2006/main" saveSubsetFonts="1">
+<p:presentation xmlns:a="http://schemas.openxmlformats.org/drawingml/2006/main" xmlns:r="http://schemas.openxmlformats.org/officeDocument/2006/relationships" xmlns:p="http://schemas.openxmlformats.org/presentationml/2006/main" removePersonalInfoOnSave="1" saveSubsetFonts="1">
   <p:sldMasterIdLst>
     <p:sldMasterId id="2147483648" r:id="rId1"/>
   </p:sldMasterIdLst>
@@ -261,7 +261,7 @@
           <a:p>
             <a:fld id="{860A5F91-12CC-4CB7-810B-189E2E7E9391}" type="datetimeFigureOut">
               <a:rPr lang="zh-CN" altLang="en-US" smtClean="0"/>
-              <a:t>2026/7/7</a:t>
+              <a:t>2026/10/19</a:t>
             </a:fld>
             <a:endParaRPr lang="zh-CN" altLang="en-US"/>
           </a:p>
@@ -459,7 +459,7 @@
           <a:p>
             <a:fld id="{860A5F91-12CC-4CB7-810B-189E2E7E9391}" type="datetimeFigureOut">
               <a:rPr lang="zh-CN" altLang="en-US" smtClean="0"/>
-              <a:t>2026/7/7</a:t>
+              <a:t>2026/10/19</a:t>
             </a:fld>
             <a:endParaRPr lang="zh-CN" altLang="en-US"/>
           </a:p>
@@ -667,7 +667,7 @@
           <a:p>
             <a:fld id="{860A5F91-12CC-4CB7-810B-189E2E7E9391}" type="datetimeFigureOut">
               <a:rPr lang="zh-CN" altLang="en-US" smtClean="0"/>
-              <a:t>2026/7/7</a:t>
+              <a:t>2026/10/19</a:t>
             </a:fld>
             <a:endParaRPr lang="zh-CN" altLang="en-US"/>
           </a:p>
@@ -865,7 +865,7 @@
           <a:p>
             <a:fld id="{860A5F91-12CC-4CB7-810B-189E2E7E9391}" type="datetimeFigureOut">
               <a:rPr lang="zh-CN" altLang="en-US" smtClean="0"/>
-              <a:t>2026/7/7</a:t>
+              <a:t>2026/10/19</a:t>
             </a:fld>
             <a:endParaRPr lang="zh-CN" altLang="en-US"/>
           </a:p>
@@ -1140,7 +1140,7 @@
           <a:p>
             <a:fld id="{860A5F91-12CC-4CB7-810B-189E2E7E9391}" type="datetimeFigureOut">
               <a:rPr lang="zh-CN" altLang="en-US" smtClean="0"/>
-              <a:t>2026/7/7</a:t>
+              <a:t>2026/10/19</a:t>
             </a:fld>
             <a:endParaRPr lang="zh-CN" altLang="en-US"/>
           </a:p>
@@ -1405,7 +1405,7 @@
           <a:p>
             <a:fld id="{860A5F91-12CC-4CB7-810B-189E2E7E9391}" type="datetimeFigureOut">
               <a:rPr lang="zh-CN" altLang="en-US" smtClean="0"/>
-              <a:t>2026/7/7</a:t>
+              <a:t>2026/10/19</a:t>
             </a:fld>
             <a:endParaRPr lang="zh-CN" altLang="en-US"/>
           </a:p>
@@ -1817,7 +1817,7 @@
           <a:p>
             <a:fld id="{860A5F91-12CC-4CB7-810B-189E2E7E9391}" type="datetimeFigureOut">
               <a:rPr lang="zh-CN" altLang="en-US" smtClean="0"/>
-              <a:t>2026/7/7</a:t>
+              <a:t>2026/10/19</a:t>
             </a:fld>
             <a:endParaRPr lang="zh-CN" altLang="en-US"/>
           </a:p>
@@ -1958,7 +1958,7 @@
           <a:p>
             <a:fld id="{860A5F91-12CC-4CB7-810B-189E2E7E9391}" type="datetimeFigureOut">
               <a:rPr lang="zh-CN" altLang="en-US" smtClean="0"/>
-              <a:t>2026/7/7</a:t>
+              <a:t>2026/10/19</a:t>
             </a:fld>
             <a:endParaRPr lang="zh-CN" altLang="en-US"/>
           </a:p>
@@ -2071,7 +2071,7 @@
           <a:p>
             <a:fld id="{860A5F91-12CC-4CB7-810B-189E2E7E9391}" type="datetimeFigureOut">
               <a:rPr lang="zh-CN" altLang="en-US" smtClean="0"/>
-              <a:t>2026/7/7</a:t>
+              <a:t>2026/10/19</a:t>
             </a:fld>
             <a:endParaRPr lang="zh-CN" altLang="en-US"/>
           </a:p>
@@ -2382,7 +2382,7 @@
           <a:p>
             <a:fld id="{860A5F91-12CC-4CB7-810B-189E2E7E9391}" type="datetimeFigureOut">
               <a:rPr lang="zh-CN" altLang="en-US" smtClean="0"/>
-              <a:t>2026/7/7</a:t>
+              <a:t>2026/10/19</a:t>
             </a:fld>
             <a:endParaRPr lang="zh-CN" altLang="en-US"/>
           </a:p>
@@ -2670,7 +2670,7 @@
           <a:p>
             <a:fld id="{860A5F91-12CC-4CB7-810B-189E2E7E9391}" type="datetimeFigureOut">
               <a:rPr lang="zh-CN" altLang="en-US" smtClean="0"/>
-              <a:t>2026/7/7</a:t>
+              <a:t>2026/10/19</a:t>
             </a:fld>
             <a:endParaRPr lang="zh-CN" altLang="en-US"/>
           </a:p>
@@ -2911,7 +2911,7 @@
           <a:p>
             <a:fld id="{860A5F91-12CC-4CB7-810B-189E2E7E9391}" type="datetimeFigureOut">
               <a:rPr lang="zh-CN" altLang="en-US" smtClean="0"/>
-              <a:t>2026/7/7</a:t>
+              <a:t>2026/10/19</a:t>
             </a:fld>
             <a:endParaRPr lang="zh-CN" altLang="en-US"/>
           </a:p>

</xml_diff>